<commit_message>
fix date format and block booking on cancelled flight
</commit_message>
<xml_diff>
--- a/FlightSense_POC_Demo_v5.pptx
+++ b/FlightSense_POC_Demo_v5.pptx
@@ -4932,7 +4932,7 @@
                 <a:ea typeface="Calibri" pitchFamily="34" charset="-122"/>
                 <a:cs typeface="Calibri" pitchFamily="34" charset="-120"/>
               </a:rPr>
-              <a:t>Partial</a:t>
+              <a:t>Met with available sources</a:t>
             </a:r>
             <a:endParaRPr lang="en-US" sz="1200" dirty="0"/>
           </a:p>
@@ -5528,7 +5528,7 @@
                 <a:ea typeface="Calibri" pitchFamily="34" charset="-122"/>
                 <a:cs typeface="Calibri" pitchFamily="34" charset="-120"/>
               </a:rPr>
-              <a:t>Not yet measured</a:t>
+              <a:t>Not applicable</a:t>
             </a:r>
             <a:endParaRPr lang="en-US" sz="1200" dirty="0"/>
           </a:p>

</xml_diff>